<commit_message>
M04: retitle away from Canva-specific naming to 'Ads Copywriting'
Julia wanted the module title to not be Canva-branded (module also
covers Meta/TikTok/Google ad copy, Canva is just the design tool used).
New title: 'Ads Copywriting Multi-Platform + Desain Siap Pakai'.

Updated everywhere the old title appeared: HTML h1 + subtitle + sidebar
nav label, PPTX cover slide + subtitle + running header on slides 2-7,
and the course outline xlsx (B5). Body content inside the module still
references Canva by name where accurate (it's still the taught tool) --
only the title-level branding changed. Folder name and pptx filename
left as-is (M04-Iklan-Canva / K3-M04-Copy-Iklan-Canva.pptx) since
renaming those wasn't asked for and risks breaking existing links.
Validated + visually QA'd the PPTX title slide and running header.
</commit_message>
<xml_diff>
--- a/Content-Marketing/M04-Iklan-Canva/K3-M04-Copy-Iklan-Canva.pptx
+++ b/Content-Marketing/M04-Iklan-Canva/K3-M04-Copy-Iklan-Canva.pptx
@@ -1428,6 +1428,10 @@
           </a:solidFill>
           <a:ln/>
         </p:spPr>
+        <p:txBody>
+          <a:bodyPr/>
+          <a:p/>
+        </p:txBody>
       </p:sp>
       <p:sp>
         <p:nvSpPr>
@@ -1503,6 +1507,10 @@
           </a:solidFill>
           <a:ln/>
         </p:spPr>
+        <p:txBody>
+          <a:bodyPr/>
+          <a:p/>
+        </p:txBody>
       </p:sp>
       <p:sp>
         <p:nvSpPr>
@@ -1618,7 +1626,7 @@
                 <a:ea typeface="Helvetica" pitchFamily="34" charset="-122"/>
                 <a:cs typeface="Helvetica" pitchFamily="34" charset="-120"/>
               </a:rPr>
-              <a:t>Copy Iklan Multi-Platform + Desain Canva</a:t>
+              <a:t>Ads Copywriting Multi-Platform + Desain Siap Pakai</a:t>
             </a:r>
             <a:endParaRPr lang="en-US" sz="4000" dirty="0"/>
           </a:p>
@@ -1657,7 +1665,7 @@
                 <a:ea typeface="Helvetica" pitchFamily="34" charset="-122"/>
                 <a:cs typeface="Helvetica" pitchFamily="34" charset="-120"/>
               </a:rPr>
-              <a:t>Claude tulis copy per platform, Canva bikin desain</a:t>
+              <a:t>Claude tulis ads copy per platform, desain tinggal susun</a:t>
             </a:r>
             <a:endParaRPr lang="en-US" sz="1550" dirty="0"/>
           </a:p>
@@ -1707,6 +1715,10 @@
           </a:solidFill>
           <a:ln/>
         </p:spPr>
+        <p:txBody>
+          <a:bodyPr/>
+          <a:p/>
+        </p:txBody>
       </p:sp>
       <p:sp>
         <p:nvSpPr>
@@ -1727,6 +1739,10 @@
           </a:solidFill>
           <a:ln/>
         </p:spPr>
+        <p:txBody>
+          <a:bodyPr/>
+          <a:p/>
+        </p:txBody>
       </p:sp>
       <p:sp>
         <p:nvSpPr>
@@ -1814,7 +1830,7 @@
                 <a:ea typeface="Helvetica" pitchFamily="34" charset="-122"/>
                 <a:cs typeface="Helvetica" pitchFamily="34" charset="-120"/>
               </a:rPr>
-              <a:t>Modul 04 — Copy Iklan Multi-Platform + Canva</a:t>
+              <a:t>Modul 04 — Ads Copywriting Multi-Platform</a:t>
             </a:r>
             <a:endParaRPr lang="en-US" sz="1250" dirty="0"/>
           </a:p>
@@ -1924,6 +1940,10 @@
             <a:prstDash val="solid"/>
           </a:ln>
         </p:spPr>
+        <p:txBody>
+          <a:bodyPr/>
+          <a:p/>
+        </p:txBody>
       </p:sp>
       <p:sp>
         <p:nvSpPr>
@@ -2032,6 +2052,10 @@
             <a:prstDash val="solid"/>
           </a:ln>
         </p:spPr>
+        <p:txBody>
+          <a:bodyPr/>
+          <a:p/>
+        </p:txBody>
       </p:sp>
       <p:sp>
         <p:nvSpPr>
@@ -2158,6 +2182,10 @@
           </a:solidFill>
           <a:ln/>
         </p:spPr>
+        <p:txBody>
+          <a:bodyPr/>
+          <a:p/>
+        </p:txBody>
       </p:sp>
       <p:sp>
         <p:nvSpPr>
@@ -2178,6 +2206,10 @@
           </a:solidFill>
           <a:ln/>
         </p:spPr>
+        <p:txBody>
+          <a:bodyPr/>
+          <a:p/>
+        </p:txBody>
       </p:sp>
       <p:sp>
         <p:nvSpPr>
@@ -2265,7 +2297,7 @@
                 <a:ea typeface="Helvetica" pitchFamily="34" charset="-122"/>
                 <a:cs typeface="Helvetica" pitchFamily="34" charset="-120"/>
               </a:rPr>
-              <a:t>Modul 04 — Copy Iklan Multi-Platform + Canva</a:t>
+              <a:t>Modul 04 — Ads Copywriting Multi-Platform</a:t>
             </a:r>
             <a:endParaRPr lang="en-US" sz="1250" dirty="0"/>
           </a:p>
@@ -2375,6 +2407,10 @@
             <a:prstDash val="solid"/>
           </a:ln>
         </p:spPr>
+        <p:txBody>
+          <a:bodyPr/>
+          <a:p/>
+        </p:txBody>
       </p:sp>
       <p:sp>
         <p:nvSpPr>
@@ -2522,6 +2558,10 @@
             <a:prstDash val="solid"/>
           </a:ln>
         </p:spPr>
+        <p:txBody>
+          <a:bodyPr/>
+          <a:p/>
+        </p:txBody>
       </p:sp>
       <p:sp>
         <p:nvSpPr>
@@ -2669,6 +2709,10 @@
             <a:prstDash val="solid"/>
           </a:ln>
         </p:spPr>
+        <p:txBody>
+          <a:bodyPr/>
+          <a:p/>
+        </p:txBody>
       </p:sp>
       <p:sp>
         <p:nvSpPr>
@@ -2816,6 +2860,10 @@
             <a:prstDash val="solid"/>
           </a:ln>
         </p:spPr>
+        <p:txBody>
+          <a:bodyPr/>
+          <a:p/>
+        </p:txBody>
       </p:sp>
       <p:sp>
         <p:nvSpPr>
@@ -2991,6 +3039,10 @@
             <a:prstDash val="solid"/>
           </a:ln>
         </p:spPr>
+        <p:txBody>
+          <a:bodyPr/>
+          <a:p/>
+        </p:txBody>
       </p:sp>
       <p:sp>
         <p:nvSpPr>
@@ -3399,6 +3451,10 @@
           </a:solidFill>
           <a:ln/>
         </p:spPr>
+        <p:txBody>
+          <a:bodyPr/>
+          <a:p/>
+        </p:txBody>
       </p:sp>
       <p:sp>
         <p:nvSpPr>
@@ -3419,6 +3475,10 @@
           </a:solidFill>
           <a:ln/>
         </p:spPr>
+        <p:txBody>
+          <a:bodyPr/>
+          <a:p/>
+        </p:txBody>
       </p:sp>
       <p:sp>
         <p:nvSpPr>
@@ -3506,7 +3566,7 @@
                 <a:ea typeface="Helvetica" pitchFamily="34" charset="-122"/>
                 <a:cs typeface="Helvetica" pitchFamily="34" charset="-120"/>
               </a:rPr>
-              <a:t>Modul 04 — Copy Iklan Multi-Platform + Canva</a:t>
+              <a:t>Modul 04 — Ads Copywriting Multi-Platform</a:t>
             </a:r>
             <a:endParaRPr lang="en-US" sz="1250" dirty="0"/>
           </a:p>
@@ -3616,6 +3676,10 @@
             <a:prstDash val="solid"/>
           </a:ln>
         </p:spPr>
+        <p:txBody>
+          <a:bodyPr/>
+          <a:p/>
+        </p:txBody>
       </p:sp>
       <p:sp>
         <p:nvSpPr>
@@ -3766,6 +3830,10 @@
             <a:prstDash val="solid"/>
           </a:ln>
         </p:spPr>
+        <p:txBody>
+          <a:bodyPr/>
+          <a:p/>
+        </p:txBody>
       </p:sp>
       <p:sp>
         <p:nvSpPr>
@@ -3934,6 +4002,10 @@
           </a:solidFill>
           <a:ln/>
         </p:spPr>
+        <p:txBody>
+          <a:bodyPr/>
+          <a:p/>
+        </p:txBody>
       </p:sp>
       <p:sp>
         <p:nvSpPr>
@@ -3954,6 +4026,10 @@
           </a:solidFill>
           <a:ln/>
         </p:spPr>
+        <p:txBody>
+          <a:bodyPr/>
+          <a:p/>
+        </p:txBody>
       </p:sp>
       <p:sp>
         <p:nvSpPr>
@@ -4041,7 +4117,7 @@
                 <a:ea typeface="Helvetica" pitchFamily="34" charset="-122"/>
                 <a:cs typeface="Helvetica" pitchFamily="34" charset="-120"/>
               </a:rPr>
-              <a:t>Modul 04 — Copy Iklan Multi-Platform + Canva</a:t>
+              <a:t>Modul 04 — Ads Copywriting Multi-Platform</a:t>
             </a:r>
             <a:endParaRPr lang="en-US" sz="1250" dirty="0"/>
           </a:p>
@@ -4144,6 +4220,10 @@
           </a:solidFill>
           <a:ln/>
         </p:spPr>
+        <p:txBody>
+          <a:bodyPr/>
+          <a:p/>
+        </p:txBody>
       </p:sp>
       <p:sp>
         <p:nvSpPr>
@@ -4262,6 +4342,10 @@
           </a:solidFill>
           <a:ln/>
         </p:spPr>
+        <p:txBody>
+          <a:bodyPr/>
+          <a:p/>
+        </p:txBody>
       </p:sp>
       <p:sp>
         <p:nvSpPr>
@@ -4380,6 +4464,10 @@
           </a:solidFill>
           <a:ln/>
         </p:spPr>
+        <p:txBody>
+          <a:bodyPr/>
+          <a:p/>
+        </p:txBody>
       </p:sp>
       <p:sp>
         <p:nvSpPr>
@@ -4498,6 +4586,10 @@
           </a:solidFill>
           <a:ln/>
         </p:spPr>
+        <p:txBody>
+          <a:bodyPr/>
+          <a:p/>
+        </p:txBody>
       </p:sp>
       <p:sp>
         <p:nvSpPr>
@@ -4623,6 +4715,10 @@
             <a:prstDash val="solid"/>
           </a:ln>
         </p:spPr>
+        <p:txBody>
+          <a:bodyPr/>
+          <a:p/>
+        </p:txBody>
       </p:sp>
       <p:sp>
         <p:nvSpPr>
@@ -4727,6 +4823,10 @@
           </a:solidFill>
           <a:ln/>
         </p:spPr>
+        <p:txBody>
+          <a:bodyPr/>
+          <a:p/>
+        </p:txBody>
       </p:sp>
       <p:sp>
         <p:nvSpPr>
@@ -4747,6 +4847,10 @@
           </a:solidFill>
           <a:ln/>
         </p:spPr>
+        <p:txBody>
+          <a:bodyPr/>
+          <a:p/>
+        </p:txBody>
       </p:sp>
       <p:sp>
         <p:nvSpPr>
@@ -4834,7 +4938,7 @@
                 <a:ea typeface="Helvetica" pitchFamily="34" charset="-122"/>
                 <a:cs typeface="Helvetica" pitchFamily="34" charset="-120"/>
               </a:rPr>
-              <a:t>Modul 04 — Copy Iklan Multi-Platform + Canva</a:t>
+              <a:t>Modul 04 — Ads Copywriting Multi-Platform</a:t>
             </a:r>
             <a:endParaRPr lang="en-US" sz="1250" dirty="0"/>
           </a:p>
@@ -4986,6 +5090,10 @@
             <a:prstDash val="solid"/>
           </a:ln>
         </p:spPr>
+        <p:txBody>
+          <a:bodyPr/>
+          <a:p/>
+        </p:txBody>
       </p:sp>
       <p:sp>
         <p:nvSpPr>
@@ -5006,6 +5114,10 @@
           </a:solidFill>
           <a:ln/>
         </p:spPr>
+        <p:txBody>
+          <a:bodyPr/>
+          <a:p/>
+        </p:txBody>
       </p:sp>
       <p:sp>
         <p:nvSpPr>
@@ -5028,6 +5140,10 @@
           </a:solidFill>
           <a:ln/>
         </p:spPr>
+        <p:txBody>
+          <a:bodyPr/>
+          <a:p/>
+        </p:txBody>
       </p:sp>
       <p:sp>
         <p:nvSpPr>
@@ -5175,6 +5291,10 @@
             <a:prstDash val="solid"/>
           </a:ln>
         </p:spPr>
+        <p:txBody>
+          <a:bodyPr/>
+          <a:p/>
+        </p:txBody>
       </p:sp>
       <p:sp>
         <p:nvSpPr>
@@ -5195,6 +5315,10 @@
           </a:solidFill>
           <a:ln/>
         </p:spPr>
+        <p:txBody>
+          <a:bodyPr/>
+          <a:p/>
+        </p:txBody>
       </p:sp>
       <p:sp>
         <p:nvSpPr>
@@ -5217,6 +5341,10 @@
           </a:solidFill>
           <a:ln/>
         </p:spPr>
+        <p:txBody>
+          <a:bodyPr/>
+          <a:p/>
+        </p:txBody>
       </p:sp>
       <p:sp>
         <p:nvSpPr>
@@ -5364,6 +5492,10 @@
             <a:prstDash val="solid"/>
           </a:ln>
         </p:spPr>
+        <p:txBody>
+          <a:bodyPr/>
+          <a:p/>
+        </p:txBody>
       </p:sp>
       <p:sp>
         <p:nvSpPr>
@@ -5384,6 +5516,10 @@
           </a:solidFill>
           <a:ln/>
         </p:spPr>
+        <p:txBody>
+          <a:bodyPr/>
+          <a:p/>
+        </p:txBody>
       </p:sp>
       <p:sp>
         <p:nvSpPr>
@@ -5406,6 +5542,10 @@
           </a:solidFill>
           <a:ln/>
         </p:spPr>
+        <p:txBody>
+          <a:bodyPr/>
+          <a:p/>
+        </p:txBody>
       </p:sp>
       <p:sp>
         <p:nvSpPr>
@@ -5553,6 +5693,10 @@
             <a:prstDash val="solid"/>
           </a:ln>
         </p:spPr>
+        <p:txBody>
+          <a:bodyPr/>
+          <a:p/>
+        </p:txBody>
       </p:sp>
       <p:sp>
         <p:nvSpPr>
@@ -5657,6 +5801,10 @@
           </a:solidFill>
           <a:ln/>
         </p:spPr>
+        <p:txBody>
+          <a:bodyPr/>
+          <a:p/>
+        </p:txBody>
       </p:sp>
       <p:sp>
         <p:nvSpPr>
@@ -5677,6 +5825,10 @@
           </a:solidFill>
           <a:ln/>
         </p:spPr>
+        <p:txBody>
+          <a:bodyPr/>
+          <a:p/>
+        </p:txBody>
       </p:sp>
       <p:sp>
         <p:nvSpPr>
@@ -5764,7 +5916,7 @@
                 <a:ea typeface="Helvetica" pitchFamily="34" charset="-122"/>
                 <a:cs typeface="Helvetica" pitchFamily="34" charset="-120"/>
               </a:rPr>
-              <a:t>Modul 04 — Copy Iklan Multi-Platform + Canva</a:t>
+              <a:t>Modul 04 — Ads Copywriting Multi-Platform</a:t>
             </a:r>
             <a:endParaRPr lang="en-US" sz="1250" dirty="0"/>
           </a:p>
@@ -5874,6 +6026,10 @@
             <a:prstDash val="solid"/>
           </a:ln>
         </p:spPr>
+        <p:txBody>
+          <a:bodyPr/>
+          <a:p/>
+        </p:txBody>
       </p:sp>
       <p:sp>
         <p:nvSpPr>
@@ -5982,6 +6138,10 @@
             <a:prstDash val="solid"/>
           </a:ln>
         </p:spPr>
+        <p:txBody>
+          <a:bodyPr/>
+          <a:p/>
+        </p:txBody>
       </p:sp>
       <p:sp>
         <p:nvSpPr>
@@ -6046,6 +6206,10 @@
           </a:solidFill>
           <a:ln/>
         </p:spPr>
+        <p:txBody>
+          <a:bodyPr/>
+          <a:p/>
+        </p:txBody>
       </p:sp>
       <p:sp>
         <p:nvSpPr>

</xml_diff>